<commit_message>
Update uploads/22BAD029- Eraianbu R _Coursera_.pptx
</commit_message>
<xml_diff>
--- a/uploads/22BAD029- Eraianbu R _Coursera_.pptx
+++ b/uploads/22BAD029- Eraianbu R _Coursera_.pptx
@@ -200,7 +200,7 @@
           <a:p>
             <a:fld id="{C0FF6D76-564D-44E3-8FF1-340E11620CC5}" type="datetimeFigureOut">
               <a:rPr lang="en-GB" smtClean="0"/>
-              <a:t>26/04/2026</a:t>
+              <a:t>25/04/2026</a:t>
             </a:fld>
             <a:endParaRPr lang="en-GB"/>
           </a:p>
@@ -584,7 +584,7 @@
           <a:p>
             <a:fld id="{CBD6940D-3C9F-4D46-8911-4D26D800F40B}" type="datetime1">
               <a:rPr lang="en-GB" smtClean="0"/>
-              <a:t>26/04/2026</a:t>
+              <a:t>25/04/2026</a:t>
             </a:fld>
             <a:endParaRPr lang="en-GB"/>
           </a:p>
@@ -845,7 +845,7 @@
           <a:p>
             <a:fld id="{D43251DB-B514-4A9C-B465-D7BBFEC77155}" type="datetime1">
               <a:rPr lang="en-GB" smtClean="0"/>
-              <a:t>26/04/2026</a:t>
+              <a:t>25/04/2026</a:t>
             </a:fld>
             <a:endParaRPr lang="en-GB"/>
           </a:p>
@@ -1058,7 +1058,7 @@
           <a:p>
             <a:fld id="{668115BA-9947-4D2B-86AE-F48A87C4C572}" type="datetime1">
               <a:rPr lang="en-GB" smtClean="0"/>
-              <a:t>26/04/2026</a:t>
+              <a:t>25/04/2026</a:t>
             </a:fld>
             <a:endParaRPr lang="en-GB"/>
           </a:p>
@@ -1266,7 +1266,7 @@
           <a:p>
             <a:fld id="{460A7482-0FA0-4ACC-9F0E-F681B72388BA}" type="datetime1">
               <a:rPr lang="en-GB" smtClean="0"/>
-              <a:t>26/04/2026</a:t>
+              <a:t>25/04/2026</a:t>
             </a:fld>
             <a:endParaRPr lang="en-GB"/>
           </a:p>
@@ -1592,7 +1592,7 @@
           <a:p>
             <a:fld id="{15ECE228-DAB8-41AE-88CF-615694F66736}" type="datetime1">
               <a:rPr lang="en-GB" smtClean="0"/>
-              <a:t>26/04/2026</a:t>
+              <a:t>25/04/2026</a:t>
             </a:fld>
             <a:endParaRPr lang="en-GB"/>
           </a:p>
@@ -1863,7 +1863,7 @@
           <a:p>
             <a:fld id="{9687AEE5-0A3F-4FA8-A850-1391F40FEC9B}" type="datetime1">
               <a:rPr lang="en-GB" smtClean="0"/>
-              <a:t>26/04/2026</a:t>
+              <a:t>25/04/2026</a:t>
             </a:fld>
             <a:endParaRPr lang="en-GB"/>
           </a:p>
@@ -2281,7 +2281,7 @@
           <a:p>
             <a:fld id="{B4CDC981-54F6-49A9-B671-8813A0F1282D}" type="datetime1">
               <a:rPr lang="en-GB" smtClean="0"/>
-              <a:t>26/04/2026</a:t>
+              <a:t>25/04/2026</a:t>
             </a:fld>
             <a:endParaRPr lang="en-GB"/>
           </a:p>
@@ -2426,7 +2426,7 @@
           <a:p>
             <a:fld id="{85EFB3D8-0B0C-48F5-96A7-90DC07D7F402}" type="datetime1">
               <a:rPr lang="en-GB" smtClean="0"/>
-              <a:t>26/04/2026</a:t>
+              <a:t>25/04/2026</a:t>
             </a:fld>
             <a:endParaRPr lang="en-GB"/>
           </a:p>
@@ -2542,7 +2542,7 @@
           <a:p>
             <a:fld id="{35884694-D9D6-4228-8F53-77DC1C4B512D}" type="datetime1">
               <a:rPr lang="en-GB" smtClean="0"/>
-              <a:t>26/04/2026</a:t>
+              <a:t>25/04/2026</a:t>
             </a:fld>
             <a:endParaRPr lang="en-GB"/>
           </a:p>
@@ -2858,7 +2858,7 @@
           <a:p>
             <a:fld id="{5871446D-0213-4038-920E-779BDBF63482}" type="datetime1">
               <a:rPr lang="en-GB" smtClean="0"/>
-              <a:t>26/04/2026</a:t>
+              <a:t>25/04/2026</a:t>
             </a:fld>
             <a:endParaRPr lang="en-GB"/>
           </a:p>
@@ -3150,7 +3150,7 @@
           <a:p>
             <a:fld id="{304A372C-505B-469E-A7DC-C0CC2EB43E2D}" type="datetime1">
               <a:rPr lang="en-GB" smtClean="0"/>
-              <a:t>26/04/2026</a:t>
+              <a:t>25/04/2026</a:t>
             </a:fld>
             <a:endParaRPr lang="en-GB"/>
           </a:p>
@@ -3396,7 +3396,7 @@
           <a:p>
             <a:fld id="{267C770F-AB3C-497F-9809-EA73C33463B8}" type="datetime1">
               <a:rPr lang="en-GB" smtClean="0"/>
-              <a:t>26/04/2026</a:t>
+              <a:t>25/04/2026</a:t>
             </a:fld>
             <a:endParaRPr lang="en-GB"/>
           </a:p>
@@ -4039,7 +4039,7 @@
           <a:p>
             <a:fld id="{B3D8CACC-C818-4E02-9ECE-C31ABD83BEC7}" type="datetime1">
               <a:rPr lang="en-GB" smtClean="0"/>
-              <a:t>26/04/2026</a:t>
+              <a:t>25/04/2026</a:t>
             </a:fld>
             <a:endParaRPr lang="en-GB"/>
           </a:p>
@@ -4269,7 +4269,7 @@
           <a:p>
             <a:fld id="{5BF74425-2C69-4C43-86DB-8D50EF156A64}" type="datetime1">
               <a:rPr lang="en-GB" smtClean="0"/>
-              <a:t>26/04/2026</a:t>
+              <a:t>25/04/2026</a:t>
             </a:fld>
             <a:endParaRPr lang="en-GB"/>
           </a:p>
@@ -4561,7 +4561,7 @@
           <a:p>
             <a:fld id="{460A7482-0FA0-4ACC-9F0E-F681B72388BA}" type="datetime1">
               <a:rPr lang="en-GB" smtClean="0"/>
-              <a:t>26/04/2026</a:t>
+              <a:t>25/04/2026</a:t>
             </a:fld>
             <a:endParaRPr lang="en-GB"/>
           </a:p>
@@ -4942,7 +4942,7 @@
                 <a:tabLst/>
                 <a:defRPr/>
               </a:pPr>
-              <a:t>26/04/2026</a:t>
+              <a:t>25/04/2026</a:t>
             </a:fld>
             <a:endParaRPr kumimoji="0" lang="en-GB" sz="1200" b="0" i="0" u="none" strike="noStrike" kern="1200" cap="none" spc="0" normalizeH="0" baseline="0" noProof="0">
               <a:ln>
@@ -5783,16 +5783,6 @@
 </file>
 
 <file path=customXml/item1.xml><?xml version="1.0" encoding="utf-8"?>
-<p:properties xmlns:p="http://schemas.microsoft.com/office/2006/metadata/properties" xmlns:xsi="http://www.w3.org/2001/XMLSchema-instance" xmlns:pc="http://schemas.microsoft.com/office/infopath/2007/PartnerControls">
-  <documentManagement>
-    <lcf76f155ced4ddcb4097134ff3c332f xmlns="047f370f-1dd3-4154-ba02-483414558b89">
-      <Terms xmlns="http://schemas.microsoft.com/office/infopath/2007/PartnerControls"/>
-    </lcf76f155ced4ddcb4097134ff3c332f>
-  </documentManagement>
-</p:properties>
-</file>
-
-<file path=customXml/item2.xml><?xml version="1.0" encoding="utf-8"?>
 <ct:contentTypeSchema xmlns:ct="http://schemas.microsoft.com/office/2006/metadata/contentType" xmlns:ma="http://schemas.microsoft.com/office/2006/metadata/properties/metaAttributes" ct:_="" ma:_="" ma:contentTypeName="Document" ma:contentTypeID="0x010100808AAEF4738CEC41B764599DEBE58FDB" ma:contentTypeVersion="12" ma:contentTypeDescription="Create a new document." ma:contentTypeScope="" ma:versionID="4dfd8bbf0b2749754ea82f6a26053794">
   <xsd:schema xmlns:xsd="http://www.w3.org/2001/XMLSchema" xmlns:xs="http://www.w3.org/2001/XMLSchema" xmlns:p="http://schemas.microsoft.com/office/2006/metadata/properties" xmlns:ns2="047f370f-1dd3-4154-ba02-483414558b89" xmlns:ns3="8341c729-4ec6-4fa5-8bf7-eaba9ef959d8" targetNamespace="http://schemas.microsoft.com/office/2006/metadata/properties" ma:root="true" ma:fieldsID="7fda8d01fe51e42f2dc58ccfb9ac85b4" ns2:_="" ns3:_="">
     <xsd:import namespace="047f370f-1dd3-4154-ba02-483414558b89"/>
@@ -6003,6 +5993,16 @@
 </ct:contentTypeSchema>
 </file>
 
+<file path=customXml/item2.xml><?xml version="1.0" encoding="utf-8"?>
+<p:properties xmlns:p="http://schemas.microsoft.com/office/2006/metadata/properties" xmlns:xsi="http://www.w3.org/2001/XMLSchema-instance" xmlns:pc="http://schemas.microsoft.com/office/infopath/2007/PartnerControls">
+  <documentManagement>
+    <lcf76f155ced4ddcb4097134ff3c332f xmlns="047f370f-1dd3-4154-ba02-483414558b89">
+      <Terms xmlns="http://schemas.microsoft.com/office/infopath/2007/PartnerControls"/>
+    </lcf76f155ced4ddcb4097134ff3c332f>
+  </documentManagement>
+</p:properties>
+</file>
+
 <file path=customXml/item3.xml><?xml version="1.0" encoding="utf-8"?>
 <?mso-contentType ?>
 <FormTemplates xmlns="http://schemas.microsoft.com/sharepoint/v3/contenttype/forms">
@@ -6013,17 +6013,6 @@
 </file>
 
 <file path=customXml/itemProps1.xml><?xml version="1.0" encoding="utf-8"?>
-<ds:datastoreItem xmlns:ds="http://schemas.openxmlformats.org/officeDocument/2006/customXml" ds:itemID="{D9FC9C11-D5D9-4425-A865-2B73309148E1}">
-  <ds:schemaRefs>
-    <ds:schemaRef ds:uri="http://schemas.microsoft.com/office/2006/metadata/properties"/>
-    <ds:schemaRef ds:uri="http://www.w3.org/2000/xmlns/"/>
-    <ds:schemaRef ds:uri="047f370f-1dd3-4154-ba02-483414558b89"/>
-    <ds:schemaRef ds:uri="http://schemas.microsoft.com/office/infopath/2007/PartnerControls"/>
-  </ds:schemaRefs>
-</ds:datastoreItem>
-</file>
-
-<file path=customXml/itemProps2.xml><?xml version="1.0" encoding="utf-8"?>
 <ds:datastoreItem xmlns:ds="http://schemas.openxmlformats.org/officeDocument/2006/customXml" ds:itemID="{9A85966F-02CA-49E1-A757-980CADCE1A9D}">
   <ds:schemaRefs>
     <ds:schemaRef ds:uri="http://schemas.microsoft.com/office/2006/metadata/contentType"/>
@@ -6032,6 +6021,24 @@
     <ds:schemaRef ds:uri="http://www.w3.org/2001/XMLSchema"/>
     <ds:schemaRef ds:uri="047f370f-1dd3-4154-ba02-483414558b89"/>
     <ds:schemaRef ds:uri="8341c729-4ec6-4fa5-8bf7-eaba9ef959d8"/>
+    <ds:schemaRef ds:uri="http://schemas.microsoft.com/office/2006/metadata/properties"/>
+    <ds:schemaRef ds:uri="http://schemas.microsoft.com/office/2006/documentManagement/types"/>
+    <ds:schemaRef ds:uri="http://schemas.microsoft.com/office/infopath/2007/PartnerControls"/>
+    <ds:schemaRef ds:uri="http://schemas.openxmlformats.org/package/2006/metadata/core-properties"/>
+    <ds:schemaRef ds:uri="http://purl.org/dc/elements/1.1/"/>
+    <ds:schemaRef ds:uri="http://purl.org/dc/terms/"/>
+    <ds:schemaRef ds:uri="http://schemas.microsoft.com/internal/obd"/>
+  </ds:schemaRefs>
+</ds:datastoreItem>
+</file>
+
+<file path=customXml/itemProps2.xml><?xml version="1.0" encoding="utf-8"?>
+<ds:datastoreItem xmlns:ds="http://schemas.openxmlformats.org/officeDocument/2006/customXml" ds:itemID="{D9FC9C11-D5D9-4425-A865-2B73309148E1}">
+  <ds:schemaRefs>
+    <ds:schemaRef ds:uri="http://schemas.microsoft.com/office/2006/metadata/properties"/>
+    <ds:schemaRef ds:uri="http://www.w3.org/2000/xmlns/"/>
+    <ds:schemaRef ds:uri="047f370f-1dd3-4154-ba02-483414558b89"/>
+    <ds:schemaRef ds:uri="http://schemas.microsoft.com/office/infopath/2007/PartnerControls"/>
   </ds:schemaRefs>
 </ds:datastoreItem>
 </file>

</xml_diff>